<commit_message>
Trim submission to the requested deliverables
Remove the browser test console, call intake, sentence TTS cache, deploy files and endpoint probe scripts; update docs and slides to match.
</commit_message>
<xml_diff>
--- a/slides/PulseNest_Support_Assistant.pptx
+++ b/slides/PulseNest_Support_Assistant.pptx
@@ -116,26 +116,26 @@
   <p:extLst>
     <p:ext uri="{521415D9-36F7-43E2-AB2F-B90AF26B5E84}">
       <p14:sectionLst xmlns:p14="http://schemas.microsoft.com/office/powerpoint/2010/main">
-        <p14:section name="Overview" id="{6b28ce74-7575-99f0-06af-f68b294e6f6d}">
+        <p14:section name="Overview" id="{a0ab5339-8ac2-08cc-50d2-714c9ffbb573}">
           <p14:sldIdLst>
             <p14:sldId id="256"/>
             <p14:sldId id="257"/>
           </p14:sldIdLst>
         </p14:section>
-        <p14:section name="Part A" id="{71a85832-8e5e-a205-99a6-b4e7538ec90a}">
+        <p14:section name="Part A" id="{3189839b-3209-9689-dbc4-1b7f903b1f67}">
           <p14:sldIdLst>
             <p14:sldId id="258"/>
             <p14:sldId id="259"/>
           </p14:sldIdLst>
         </p14:section>
-        <p14:section name="Part B" id="{5c850451-5c72-81f1-a2ab-1eeca5765e83}">
+        <p14:section name="Part B" id="{4782cae0-4d65-c34e-f95d-8588048b71fb}">
           <p14:sldIdLst>
             <p14:sldId id="260"/>
             <p14:sldId id="261"/>
             <p14:sldId id="262"/>
           </p14:sldIdLst>
         </p14:section>
-        <p14:section name="Part C" id="{205c9706-4fd7-9ab8-9aab-c65f147a8152}">
+        <p14:section name="Part C" id="{0e6662f6-8567-595e-8d8c-9da2214a11ea}">
           <p14:sldIdLst>
             <p14:sldId id="263"/>
             <p14:sldId id="264"/>
@@ -3144,7 +3144,7 @@
                   <a:schemeClr val="tx1"/>
                 </a:solidFill>
               </a:rPr>
-              <a:t>Same pipeline, channel=voice; intake asks name + order id up front</a:t>
+              <a:t>Same text pipeline and guards (channel=voice)</a:t>
             </a:r>
             <a:endParaRPr lang="en-US" sz="1200" dirty="0"/>
           </a:p>

</xml_diff>

<commit_message>
Run voice scenarios on real recordings with Groq; switch STT to whisper-large-v3
- Real caller clips for all scenarios; new runs replace the synthetic in-house ones
- Groq retired the llama defaults: roles now on gpt-oss-20b (router), gpt-oss-120b (guards), qwen3.8-27b (agent), each its own rate-limit bucket
- reasoning_effort setting for Groq; circuit breaker per model
- whisper-large-v3 instead of turbo: turbo dropped a digit from every spoken order id
- Paced text eval option; design note B, red team, decisions log and slides updated
</commit_message>
<xml_diff>
--- a/slides/PulseNest_Support_Assistant.pptx
+++ b/slides/PulseNest_Support_Assistant.pptx
@@ -116,26 +116,26 @@
   <p:extLst>
     <p:ext uri="{521415D9-36F7-43E2-AB2F-B90AF26B5E84}">
       <p14:sectionLst xmlns:p14="http://schemas.microsoft.com/office/powerpoint/2010/main">
-        <p14:section name="Overview" id="{a0ab5339-8ac2-08cc-50d2-714c9ffbb573}">
+        <p14:section name="Overview" id="{af99846c-e4c1-5611-9aaf-a156af46bb85}">
           <p14:sldIdLst>
             <p14:sldId id="256"/>
             <p14:sldId id="257"/>
           </p14:sldIdLst>
         </p14:section>
-        <p14:section name="Part A" id="{3189839b-3209-9689-dbc4-1b7f903b1f67}">
+        <p14:section name="Part A" id="{38e43712-0ecd-4b97-ca5e-2fc1b93edcf0}">
           <p14:sldIdLst>
             <p14:sldId id="258"/>
             <p14:sldId id="259"/>
           </p14:sldIdLst>
         </p14:section>
-        <p14:section name="Part B" id="{4782cae0-4d65-c34e-f95d-8588048b71fb}">
+        <p14:section name="Part B" id="{7bbb3ebe-bca7-92d0-e5f0-877ec83b7aba}">
           <p14:sldIdLst>
             <p14:sldId id="260"/>
             <p14:sldId id="261"/>
             <p14:sldId id="262"/>
           </p14:sldIdLst>
         </p14:section>
-        <p14:section name="Part C" id="{0e6662f6-8567-595e-8d8c-9da2214a11ea}">
+        <p14:section name="Part C" id="{141b06e4-ce80-2ced-e0b9-d781673bb56b}">
           <p14:sldIdLst>
             <p14:sldId id="263"/>
             <p14:sldId id="264"/>
@@ -247,7 +247,7 @@
                     <c:v>Hangover</c:v>
                   </c:pt>
                   <c:pt idx="1">
-                    <c:v>STT (local)</c:v>
+                    <c:v>STT (Groq Whisper)</c:v>
                   </c:pt>
                   <c:pt idx="2">
                     <c:v>LLM pipeline</c:v>
@@ -269,13 +269,13 @@
                   <c:v>576</c:v>
                 </c:pt>
                 <c:pt idx="1">
-                  <c:v>2123</c:v>
+                  <c:v>669</c:v>
                 </c:pt>
                 <c:pt idx="2">
-                  <c:v>6958</c:v>
+                  <c:v>2755</c:v>
                 </c:pt>
                 <c:pt idx="3">
-                  <c:v>986</c:v>
+                  <c:v>1273</c:v>
                 </c:pt>
               </c:numCache>
             </c:numRef>
@@ -1613,7 +1613,7 @@
           <a:p>
             <a:r>
               <a:rPr lang="en-US" dirty="0"/>
-              <a:t>Full list with reasons: docs/red_team.md. All voice runs used synthetic caller audio; thresholds must be re-checked on real recordings.</a:t>
+              <a:t>Full list with reasons: docs/red_team.md. All voice runs use real recordings of one speaker on a laptop mic; accents and phone-line audio are untested.</a:t>
             </a:r>
             <a:endParaRPr lang="en-US" dirty="0"/>
           </a:p>
@@ -4631,7 +4631,7 @@
                           <a:ea typeface="Calibri" pitchFamily="34" charset="-122"/>
                           <a:cs typeface="Calibri" pitchFamily="34" charset="-120"/>
                         </a:rPr>
-                        <a:t>Scenario (real TTS, Silero, synthetic caller clips)</a:t>
+                        <a:t>Scenario (real recorded caller clips, Groq, Silero)</a:t>
                       </a:r>
                       <a:endParaRPr lang="en-US" sz="1200" dirty="0">
                         <a:latin typeface="Calibri" charset="0"/>
@@ -4907,7 +4907,7 @@
                           <a:ea typeface="Calibri" pitchFamily="34" charset="-122"/>
                           <a:cs typeface="Calibri" pitchFamily="34" charset="-120"/>
                         </a:rPr>
-                        <a:t>120 ms clap during reply</a:t>
+                        <a:t>Real clap / keyboard typing during reply</a:t>
                       </a:r>
                       <a:endParaRPr lang="en-US" sz="1200" dirty="0">
                         <a:latin typeface="Calibri" charset="0"/>
@@ -5113,7 +5113,7 @@
                           <a:ea typeface="Calibri" pitchFamily="34" charset="-122"/>
                           <a:cs typeface="Calibri" pitchFamily="34" charset="-120"/>
                         </a:rPr>
-                        <a:t>cut at 2.3 s of 14.3 s; one new turn</a:t>
+                        <a:t>cut ~0.8 s after caller starts; one new turn</a:t>
                       </a:r>
                       <a:endParaRPr lang="en-US" sz="1200" dirty="0">
                         <a:latin typeface="Calibri" charset="0"/>
@@ -5251,7 +5251,7 @@
                           <a:ea typeface="Calibri" pitchFamily="34" charset="-122"/>
                           <a:cs typeface="Calibri" pitchFamily="34" charset="-120"/>
                         </a:rPr>
-                        <a:t>first ignored, second cuts; exactly 2 turns</a:t>
+                        <a:t>first ducks and resumes, second cuts; 2 turns</a:t>
                       </a:r>
                       <a:endParaRPr lang="en-US" sz="1200" dirty="0">
                         <a:latin typeface="Calibri" charset="0"/>
@@ -5818,7 +5818,7 @@
                 <a:ea typeface="Cambria" pitchFamily="34" charset="-122"/>
                 <a:cs typeface="Cambria" pitchFamily="34" charset="-120"/>
               </a:rPr>
-              <a:t>10.6 s</a:t>
+              <a:t>5.3 s</a:t>
             </a:r>
             <a:endParaRPr lang="en-US" sz="3600" dirty="0"/>
           </a:p>
@@ -5854,7 +5854,7 @@
                   <a:schemeClr val="tx1"/>
                 </a:solidFill>
               </a:rPr>
-              <a:t>end of speech → first answer audio, p50 (p95 16.4 s)</a:t>
+              <a:t>end of speech → first answer audio, p50 (p95 6.5 s)</a:t>
             </a:r>
             <a:endParaRPr lang="en-US" sz="1100" dirty="0"/>
           </a:p>
@@ -5890,7 +5890,7 @@
                   <a:schemeClr val="tx1"/>
                 </a:solidFill>
               </a:rPr>
-              <a:t>Clock starts at the caller's last voiced 32 ms frame. LLM ≈ 65%: in-house server at ~10 tokens/s, 3–4 sequential calls. STT is local because no Groq key was set.</a:t>
+              <a:t>Real recorded caller clips on Groq. Clock starts at the caller's last voiced 32 ms frame. LLM ≈ 52%: 4–5 sequential calls at 0.3–0.7 s. In-house server was 10.6 s.</a:t>
             </a:r>
             <a:endParaRPr lang="en-US" sz="1100" dirty="0"/>
           </a:p>

</xml_diff>

<commit_message>
Handle "ok, stop", file one ticket per session, delay the filler to 3 s
From a live browser call: "Okay, stop." was routed as a request and each one filed another
human ticket. A bare stop/wait now ends with an offer to help, escalation reuses the session's
open ticket, and "one moment" waits 3 s instead of firing on nearly every turn.
</commit_message>
<xml_diff>
--- a/slides/PulseNest_Support_Assistant.pptx
+++ b/slides/PulseNest_Support_Assistant.pptx
@@ -116,26 +116,26 @@
   <p:extLst>
     <p:ext uri="{521415D9-36F7-43E2-AB2F-B90AF26B5E84}">
       <p14:sectionLst xmlns:p14="http://schemas.microsoft.com/office/powerpoint/2010/main">
-        <p14:section name="Overview" id="{af99846c-e4c1-5611-9aaf-a156af46bb85}">
+        <p14:section name="Overview" id="{b0e466c7-557a-80af-61fa-8def7d3c2a4f}">
           <p14:sldIdLst>
             <p14:sldId id="256"/>
             <p14:sldId id="257"/>
           </p14:sldIdLst>
         </p14:section>
-        <p14:section name="Part A" id="{38e43712-0ecd-4b97-ca5e-2fc1b93edcf0}">
+        <p14:section name="Part A" id="{1e44711b-d5ea-0ef9-98de-10ac7df86ca3}">
           <p14:sldIdLst>
             <p14:sldId id="258"/>
             <p14:sldId id="259"/>
           </p14:sldIdLst>
         </p14:section>
-        <p14:section name="Part B" id="{7bbb3ebe-bca7-92d0-e5f0-877ec83b7aba}">
+        <p14:section name="Part B" id="{2029da25-92c8-d97c-0dd8-c0a050ff273d}">
           <p14:sldIdLst>
             <p14:sldId id="260"/>
             <p14:sldId id="261"/>
             <p14:sldId id="262"/>
           </p14:sldIdLst>
         </p14:section>
-        <p14:section name="Part C" id="{141b06e4-ce80-2ced-e0b9-d781673bb56b}">
+        <p14:section name="Part C" id="{66ac3f76-751c-2aec-86b5-047d49f9a847}">
           <p14:sldIdLst>
             <p14:sldId id="263"/>
             <p14:sldId id="264"/>
@@ -5779,7 +5779,7 @@
                   <a:schemeClr val="tx1"/>
                 </a:solidFill>
               </a:rPr>
-              <a:t>end of speech → first audio (filler), p50</a:t>
+              <a:t>end of speech → first audio (filler at 0.8 s; now 3 s), p50</a:t>
             </a:r>
             <a:endParaRPr lang="en-US" sz="1100" dirty="0"/>
           </a:p>

</xml_diff>

<commit_message>
Groq text eval results; update design note A, red team and slides
</commit_message>
<xml_diff>
--- a/slides/PulseNest_Support_Assistant.pptx
+++ b/slides/PulseNest_Support_Assistant.pptx
@@ -116,26 +116,26 @@
   <p:extLst>
     <p:ext uri="{521415D9-36F7-43E2-AB2F-B90AF26B5E84}">
       <p14:sectionLst xmlns:p14="http://schemas.microsoft.com/office/powerpoint/2010/main">
-        <p14:section name="Overview" id="{b0e466c7-557a-80af-61fa-8def7d3c2a4f}">
+        <p14:section name="Overview" id="{43810442-2e70-673f-9000-63cae38fc93e}">
           <p14:sldIdLst>
             <p14:sldId id="256"/>
             <p14:sldId id="257"/>
           </p14:sldIdLst>
         </p14:section>
-        <p14:section name="Part A" id="{1e44711b-d5ea-0ef9-98de-10ac7df86ca3}">
+        <p14:section name="Part A" id="{fc1fdd9c-cb20-f0e7-3ad0-b7a07753375e}">
           <p14:sldIdLst>
             <p14:sldId id="258"/>
             <p14:sldId id="259"/>
           </p14:sldIdLst>
         </p14:section>
-        <p14:section name="Part B" id="{2029da25-92c8-d97c-0dd8-c0a050ff273d}">
+        <p14:section name="Part B" id="{5255d7d0-86a1-c606-fe8f-f8d643aa535e}">
           <p14:sldIdLst>
             <p14:sldId id="260"/>
             <p14:sldId id="261"/>
             <p14:sldId id="262"/>
           </p14:sldIdLst>
         </p14:section>
-        <p14:section name="Part C" id="{66ac3f76-751c-2aec-86b5-047d49f9a847}">
+        <p14:section name="Part C" id="{1e7b401c-0fe6-d37f-fa23-028e9655e591}">
           <p14:sldIdLst>
             <p14:sldId id="263"/>
             <p14:sldId id="264"/>
@@ -1173,7 +1173,7 @@
           <a:p>
             <a:r>
               <a:rPr lang="en-US" dirty="0"/>
-              <a:t>Model: in-house Qwen3.8-27B-AWQ-INT4. Source: eval/results/text_eval_2026-10-19.json.</a:t>
+              <a:t>Groq: router gpt-oss-20b, guard gpt-oss-120b. Source: eval/results/text_eval_2026-10-20.json.</a:t>
             </a:r>
             <a:endParaRPr lang="en-US" dirty="0"/>
           </a:p>
@@ -3698,7 +3698,7 @@
                 <a:ea typeface="Cambria" pitchFamily="34" charset="-122"/>
                 <a:cs typeface="Cambria" pitchFamily="34" charset="-120"/>
               </a:rPr>
-              <a:t>Measured, including where it degrades</a:t>
+              <a:t>Measured on Groq, including where it degrades</a:t>
             </a:r>
             <a:endParaRPr lang="en-US" sz="2800" dirty="0"/>
           </a:p>
@@ -3737,7 +3737,7 @@
                 <a:ea typeface="Cambria" pitchFamily="34" charset="-122"/>
                 <a:cs typeface="Cambria" pitchFamily="34" charset="-120"/>
               </a:rPr>
-              <a:t>80%</a:t>
+              <a:t>85%</a:t>
             </a:r>
             <a:endParaRPr lang="en-US" sz="3600" dirty="0"/>
           </a:p>
@@ -3812,7 +3812,7 @@
                 <a:ea typeface="Cambria" pitchFamily="34" charset="-122"/>
                 <a:cs typeface="Cambria" pitchFamily="34" charset="-120"/>
               </a:rPr>
-              <a:t>88%</a:t>
+              <a:t>83%</a:t>
             </a:r>
             <a:endParaRPr lang="en-US" sz="3600" dirty="0"/>
           </a:p>
@@ -3848,7 +3848,7 @@
                   <a:schemeClr val="tx1"/>
                 </a:solidFill>
               </a:rPr>
-              <a:t>guard recall, PulseNest attacks (42 rows)</a:t>
+              <a:t>guard recall, PulseNest attacks, rules only (42 rows)</a:t>
             </a:r>
             <a:endParaRPr lang="en-US" sz="1100" dirty="0"/>
           </a:p>
@@ -3962,7 +3962,7 @@
                 <a:ea typeface="Cambria" pitchFamily="34" charset="-122"/>
                 <a:cs typeface="Cambria" pitchFamily="34" charset="-120"/>
               </a:rPr>
-              <a:t>51%</a:t>
+              <a:t>94%</a:t>
             </a:r>
             <a:endParaRPr lang="en-US" sz="3600" dirty="0"/>
           </a:p>
@@ -4061,7 +4061,7 @@
                   <a:schemeClr val="accent4"/>
                 </a:solidFill>
               </a:rPr>
-              <a:t>Read with the load caveat</a:t>
+              <a:t>Read with the caveats</a:t>
             </a:r>
             <a:endParaRPr lang="en-US" sz="1500" dirty="0"/>
           </a:p>
@@ -4101,7 +4101,7 @@
                   <a:schemeClr val="tx1"/>
                 </a:solidFill>
               </a:rPr>
-              <a:t>Run at 12 concurrent turns: 63/180 routes and most guard checks fell back to deterministic paths (LLM budgets exceeded)</a:t>
+              <a:t>Routing on Groq: 3/180 routes fell back; weak spot return_refund recall 58%, mostly to escalation</a:t>
             </a:r>
             <a:endParaRPr lang="en-US" sz="1200" dirty="0"/>
           </a:p>
@@ -4119,7 +4119,7 @@
                   <a:schemeClr val="tx1"/>
                 </a:solidFill>
               </a:rPr>
-              <a:t>Generic deepset injections: recall 12% (heuristic-only), false positives 0%</a:t>
+              <a:t>Guard: the guard model hit Groq's daily token cap, so only the rule-based layer was measured (an LLM outage)</a:t>
             </a:r>
             <a:endParaRPr lang="en-US" sz="1200" dirty="0"/>
           </a:p>
@@ -4137,7 +4137,7 @@
                   <a:schemeClr val="tx1"/>
                 </a:solidFill>
               </a:rPr>
-              <a:t>Weak spot: return_refund recall 47%, mostly misrouted to escalation</a:t>
+              <a:t>Rules alone on generic deepset injections: recall 5%, false positives 0%</a:t>
             </a:r>
             <a:endParaRPr lang="en-US" sz="1200" dirty="0"/>
           </a:p>

</xml_diff>